<commit_message>
updated meta learning exercise
</commit_message>
<xml_diff>
--- a/exercises/meta_learning/meta_learning_exercise.pptx
+++ b/exercises/meta_learning/meta_learning_exercise.pptx
@@ -414,7 +414,7 @@
             <a:fld id="{57AF82F7-3B33-6D48-9626-CABC5CBE1A55}" type="datetime1">
               <a:rPr lang="it-IT" altLang="x-none"/>
               <a:pPr/>
-              <a:t>29/06/25</a:t>
+              <a:t>11/06/26</a:t>
             </a:fld>
             <a:endParaRPr lang="it-IT" altLang="x-none"/>
           </a:p>
@@ -5221,8 +5221,8 @@
           </a:p>
         </p:txBody>
       </p:sp>
-      <mc:AlternateContent xmlns:mc="http://schemas.openxmlformats.org/markup-compatibility/2006" xmlns:a14="http://schemas.microsoft.com/office/drawing/2010/main">
-        <mc:Choice Requires="a14">
+      <mc:AlternateContent xmlns:mc="http://schemas.openxmlformats.org/markup-compatibility/2006">
+        <mc:Choice xmlns:a14="http://schemas.microsoft.com/office/drawing/2010/main" Requires="a14">
           <p:sp>
             <p:nvSpPr>
               <p:cNvPr id="6" name="Content Placeholder 5">
@@ -5269,7 +5269,15 @@
                 </a:pPr>
                 <a:r>
                   <a:rPr lang="en-CH" dirty="0"/>
-                  <a:t>      DeepSet is invariant to permutations to the </a:t>
+                  <a:t>      DeepSets is </a:t>
+                </a:r>
+                <a:r>
+                  <a:rPr lang="en-CH" i="1" dirty="0"/>
+                  <a:t>invariant to permutations</a:t>
+                </a:r>
+                <a:r>
+                  <a:rPr lang="en-CH" dirty="0"/>
+                  <a:t> of the </a:t>
                 </a:r>
                 <a14:m>
                   <m:oMath xmlns:m="http://schemas.openxmlformats.org/officeDocument/2006/math">
@@ -5306,7 +5314,7 @@
             </p:txBody>
           </p:sp>
         </mc:Choice>
-        <mc:Fallback xmlns="">
+        <mc:Fallback>
           <p:sp>
             <p:nvSpPr>
               <p:cNvPr id="6" name="Content Placeholder 5">
@@ -5386,10 +5394,10 @@
       </p:pic>
       <p:pic>
         <p:nvPicPr>
-          <p:cNvPr id="9" name="Picture 8" descr="\documentclass{article}&#10;\usepackage{amsmath}&#10;\usepackage{amsfonts}&#10;\usepackage{color}&#10;\newcommand{\red}[1]{{\color{red}#1}}&#10;&#10;\pagestyle{empty}&#10;&#10;\begin{document}&#10;&#10;&#10;\begin{align*}&#10;c &amp;= \mathrm{DeepSet}_{\phi_1}(D) \\&#10;\hat y &amp;= \mathrm{MLP}_{\phi_2}(c, x).&#10;\end{align*}&#10;\end{document}" title="IguanaTex Bitmap Display">
+          <p:cNvPr id="4" name="Picture 3">
             <a:extLst>
               <a:ext uri="{FF2B5EF4-FFF2-40B4-BE49-F238E27FC236}">
-                <a16:creationId xmlns:a16="http://schemas.microsoft.com/office/drawing/2014/main" id="{4F62ABE8-ECFA-1CBA-5F55-F2722D026A99}"/>
+                <a16:creationId xmlns:a16="http://schemas.microsoft.com/office/drawing/2014/main" id="{532CF28D-EF3C-E6E5-9842-C3E420B7B573}"/>
               </a:ext>
             </a:extLst>
           </p:cNvPr>
@@ -5410,8 +5418,8 @@
         </p:blipFill>
         <p:spPr>
           <a:xfrm>
-            <a:off x="839416" y="2420888"/>
-            <a:ext cx="1805940" cy="617220"/>
+            <a:off x="839417" y="2420887"/>
+            <a:ext cx="1885493" cy="607162"/>
           </a:xfrm>
           <a:prstGeom prst="rect">
             <a:avLst/>
@@ -7581,7 +7589,7 @@
           <a:p>
             <a:r>
               <a:rPr lang="en-CH" dirty="0"/>
-              <a:t>Implementation of the in-context learning architecture for static regression DeepSet + MLP is sketched in in_context_learning_sketch.ipynb</a:t>
+              <a:t>Implementation of the in-context learning architecture for static regression DeepSets + MLP is sketched in in_context_learning_sketch.ipynb</a:t>
             </a:r>
           </a:p>
           <a:p>
@@ -7607,17 +7615,12 @@
             </a:r>
             <a:r>
               <a:rPr lang="en-GB" dirty="0"/>
-              <a:t>, described </a:t>
+              <a:t>, described in the </a:t>
             </a:r>
             <a:r>
-              <a:rPr lang="en-GB"/>
-              <a:t>in the </a:t>
-            </a:r>
-            <a:r>
-              <a:rPr lang="en-CH"/>
+              <a:rPr lang="en-CH" dirty="0"/>
               <a:t>next slides…)</a:t>
             </a:r>
-            <a:endParaRPr lang="en-CH" dirty="0"/>
           </a:p>
           <a:p>
             <a:pPr marL="0" indent="0">
@@ -7920,10 +7923,10 @@
       </mc:AlternateContent>
       <p:pic>
         <p:nvPicPr>
-          <p:cNvPr id="3" name="Picture 2" descr="\documentclass{article}&#10;\usepackage{amsmath}&#10;\usepackage{amsfonts}&#10;\usepackage{color}&#10;\newcommand{\red}[1]{{\color{red}#1}}&#10;&#10;\pagestyle{empty}&#10;&#10;\begin{document}&#10;&#10;&#10;\begin{align*}&#10;\theta &amp;= \mathrm{DeepSet}_\phi(D) \\&#10;\hat y &amp;= \mathrm{MLP}_\theta(x).&#10;\end{align*}&#10;\end{document}" title="IguanaTex Bitmap Display">
+          <p:cNvPr id="4" name="Picture 3">
             <a:extLst>
               <a:ext uri="{FF2B5EF4-FFF2-40B4-BE49-F238E27FC236}">
-                <a16:creationId xmlns:a16="http://schemas.microsoft.com/office/drawing/2014/main" id="{E23B0DC5-0F7E-FCFE-8980-405F6C7C36D5}"/>
+                <a16:creationId xmlns:a16="http://schemas.microsoft.com/office/drawing/2014/main" id="{F8C49D1E-45C0-96D5-A5DC-3EBC9E54FE50}"/>
               </a:ext>
             </a:extLst>
           </p:cNvPr>
@@ -7945,7 +7948,7 @@
         <p:spPr>
           <a:xfrm>
             <a:off x="839416" y="2420888"/>
-            <a:ext cx="1714500" cy="594360"/>
+            <a:ext cx="1795882" cy="598018"/>
           </a:xfrm>
           <a:prstGeom prst="rect">
             <a:avLst/>
@@ -9703,19 +9706,21 @@
 
 <file path=ppt/tags/tag21.xml><?xml version="1.0" encoding="utf-8"?>
 <p:tagLst xmlns:a="http://schemas.openxmlformats.org/drawingml/2006/main" xmlns:r="http://schemas.openxmlformats.org/officeDocument/2006/relationships" xmlns:p="http://schemas.openxmlformats.org/presentationml/2006/main">
-  <p:tag name="OUTPUTDPI" val="1200"/>
-  <p:tag name="ORIGINALHEIGHT" val="26"/>
-  <p:tag name="ORIGINALWIDTH" val="75"/>
-  <p:tag name="OUTPUTTYPE" val="PDF"/>
-  <p:tag name="IGUANATEXVERSION" val="160"/>
-  <p:tag name="LATEXADDIN" val="\documentclass{article}&#10;\usepackage{amsmath}&#10;\usepackage{amsfonts}&#10;\usepackage{color}&#10;\newcommand{\red}[1]{{\color{red}#1}}&#10;&#10;\pagestyle{empty}&#10;&#10;\begin{document}&#10;&#10;&#10;\begin{align*}&#10;\theta &amp;= \mathrm{DeepSet}_\phi(D) \\&#10;\hat y &amp;= \mathrm{MLP}_\theta(x).&#10;\end{align*}&#10;\end{document}"/>
+  <p:tag name="OUTPUTDPI" val=" 1200"/>
+  <p:tag name="ORIGINALHEIGHT" val=" 327"/>
+  <p:tag name="ORIGINALWIDTH" val=" 982"/>
+  <p:tag name="OUTPUTTYPE" val="PNG"/>
+  <p:tag name="IGUANATEXVERSION" val="162"/>
+  <p:tag name="LATEXADDIN" val="\documentclass{article}&#10;\usepackage{amsmath}&#10;\usepackage{amsfonts}&#10;\usepackage{color}&#10;\newcommand{\red}[1]{{\color{red}#1}}&#10;&#10;\pagestyle{empty}&#10;&#10;\begin{document}&#10;&#10;&#10;\begin{align*}&#10;\theta &amp;= \mathrm{DeepSets}_\phi(D) \\&#10;\hat y &amp;= \mathrm{MLP}_\theta(x).&#10;\end{align*}&#10;\end{document}"/>
   <p:tag name="IGUANATEXSIZE" val="18"/>
-  <p:tag name="IGUANATEXCURSOR" val="245"/>
+  <p:tag name="IGUANATEXCURSOR" val="204"/>
   <p:tag name="TRANSPARENCY" val="True"/>
+  <p:tag name="CHOOSECOLOR" val="False"/>
+  <p:tag name="COLORHEX" val="000000"/>
   <p:tag name="LATEXENGINEID" val="0"/>
   <p:tag name="TEMPFOLDER" val="/Users/marco.forgione/Library/Containers/com.microsoft.Powerpoint/Data/tmp/TemporaryItems/"/>
-  <p:tag name="LATEXFORMHEIGHT" val="426.65"/>
-  <p:tag name="LATEXFORMWIDTH" val="513.35"/>
+  <p:tag name="LATEXFORMHEIGHT" val=" 426.65"/>
+  <p:tag name="LATEXFORMWIDTH" val=" 513.35"/>
   <p:tag name="LATEXFORMWRAP" val="True"/>
   <p:tag name="BITMAPVECTOR" val="0"/>
 </p:tagLst>
@@ -10063,19 +10068,21 @@
 
 <file path=ppt/tags/tag8.xml><?xml version="1.0" encoding="utf-8"?>
 <p:tagLst xmlns:a="http://schemas.openxmlformats.org/drawingml/2006/main" xmlns:r="http://schemas.openxmlformats.org/officeDocument/2006/relationships" xmlns:p="http://schemas.openxmlformats.org/presentationml/2006/main">
-  <p:tag name="OUTPUTDPI" val="1200"/>
-  <p:tag name="ORIGINALHEIGHT" val="27"/>
-  <p:tag name="ORIGINALWIDTH" val="79"/>
-  <p:tag name="OUTPUTTYPE" val="PDF"/>
-  <p:tag name="IGUANATEXVERSION" val="160"/>
-  <p:tag name="LATEXADDIN" val="\documentclass{article}&#10;\usepackage{amsmath}&#10;\usepackage{amsfonts}&#10;\usepackage{color}&#10;\newcommand{\red}[1]{{\color{red}#1}}&#10;&#10;\pagestyle{empty}&#10;&#10;\begin{document}&#10;&#10;&#10;\begin{align*}&#10;c &amp;= \mathrm{DeepSet}_{\phi_1}(D) \\&#10;\hat y &amp;= \mathrm{MLP}_{\phi_2}(c, x).&#10;\end{align*}&#10;\end{document}"/>
+  <p:tag name="OUTPUTDPI" val=" 1200"/>
+  <p:tag name="ORIGINALHEIGHT" val=" 332"/>
+  <p:tag name="ORIGINALWIDTH" val=" 1031"/>
+  <p:tag name="OUTPUTTYPE" val="PNG"/>
+  <p:tag name="IGUANATEXVERSION" val="162"/>
+  <p:tag name="LATEXADDIN" val="\documentclass{article}&#10;\usepackage{amsmath}&#10;\usepackage{amsfonts}&#10;\usepackage{color}&#10;\newcommand{\red}[1]{{\color{red}#1}}&#10;&#10;\pagestyle{empty}&#10;&#10;\begin{document}&#10;&#10;&#10;\begin{align*}&#10;c &amp;= \mathrm{DeepSets}_{\phi_1}(D) \\&#10;\hat y &amp;= \mathrm{MLP}_{\phi_2}(c, x).&#10;\end{align*}&#10;\end{document}"/>
   <p:tag name="IGUANATEXSIZE" val="18"/>
-  <p:tag name="IGUANATEXCURSOR" val="245"/>
+  <p:tag name="IGUANATEXCURSOR" val="199"/>
   <p:tag name="TRANSPARENCY" val="True"/>
+  <p:tag name="CHOOSECOLOR" val="False"/>
+  <p:tag name="COLORHEX" val="000000"/>
   <p:tag name="LATEXENGINEID" val="0"/>
   <p:tag name="TEMPFOLDER" val="/Users/marco.forgione/Library/Containers/com.microsoft.Powerpoint/Data/tmp/TemporaryItems/"/>
-  <p:tag name="LATEXFORMHEIGHT" val="426.65"/>
-  <p:tag name="LATEXFORMWIDTH" val="513.35"/>
+  <p:tag name="LATEXFORMHEIGHT" val=" 426.65"/>
+  <p:tag name="LATEXFORMWIDTH" val=" 513.35"/>
   <p:tag name="LATEXFORMWRAP" val="True"/>
   <p:tag name="BITMAPVECTOR" val="0"/>
 </p:tagLst>
@@ -11519,6 +11526,26 @@
 </file>
 
 <file path=customXml/item1.xml><?xml version="1.0" encoding="utf-8"?>
+<p:properties xmlns:p="http://schemas.microsoft.com/office/2006/metadata/properties" xmlns:xsi="http://www.w3.org/2001/XMLSchema-instance" xmlns:pc="http://schemas.microsoft.com/office/infopath/2007/PartnerControls">
+  <documentManagement>
+    <lcf76f155ced4ddcb4097134ff3c332f xmlns="0c05fedb-ed2a-4eb3-93de-5f5a6c97bfe0">
+      <Terms xmlns="http://schemas.microsoft.com/office/infopath/2007/PartnerControls"/>
+    </lcf76f155ced4ddcb4097134ff3c332f>
+    <TaxCatchAll xmlns="c69d801c-64cd-49bc-b1b3-ec2496ede094" xsi:nil="true"/>
+  </documentManagement>
+</p:properties>
+</file>
+
+<file path=customXml/item2.xml><?xml version="1.0" encoding="utf-8"?>
+<?mso-contentType ?>
+<FormTemplates xmlns="http://schemas.microsoft.com/sharepoint/v3/contenttype/forms">
+  <Display>DocumentLibraryForm</Display>
+  <Edit>DocumentLibraryForm</Edit>
+  <New>DocumentLibraryForm</New>
+</FormTemplates>
+</file>
+
+<file path=customXml/item3.xml><?xml version="1.0" encoding="utf-8"?>
 <ct:contentTypeSchema xmlns:ct="http://schemas.microsoft.com/office/2006/metadata/contentType" xmlns:ma="http://schemas.microsoft.com/office/2006/metadata/properties/metaAttributes" ct:_="" ma:_="" ma:contentTypeName="Document" ma:contentTypeID="0x010100E943B4D0C91CA54E9BBFAD215D4A4FF7" ma:contentTypeVersion="18" ma:contentTypeDescription="Create a new document." ma:contentTypeScope="" ma:versionID="48c4930ddcec7bff74490998dd84a4c1">
   <xsd:schema xmlns:xsd="http://www.w3.org/2001/XMLSchema" xmlns:xs="http://www.w3.org/2001/XMLSchema" xmlns:p="http://schemas.microsoft.com/office/2006/metadata/properties" xmlns:ns2="0c05fedb-ed2a-4eb3-93de-5f5a6c97bfe0" xmlns:ns3="c69d801c-64cd-49bc-b1b3-ec2496ede094" targetNamespace="http://schemas.microsoft.com/office/2006/metadata/properties" ma:root="true" ma:fieldsID="dcb337392c8a5973c5e221652a72fbb4" ns2:_="" ns3:_="">
     <xsd:import namespace="0c05fedb-ed2a-4eb3-93de-5f5a6c97bfe0"/>
@@ -11773,27 +11800,32 @@
 </ct:contentTypeSchema>
 </file>
 
-<file path=customXml/item2.xml><?xml version="1.0" encoding="utf-8"?>
-<p:properties xmlns:p="http://schemas.microsoft.com/office/2006/metadata/properties" xmlns:xsi="http://www.w3.org/2001/XMLSchema-instance" xmlns:pc="http://schemas.microsoft.com/office/infopath/2007/PartnerControls">
-  <documentManagement>
-    <lcf76f155ced4ddcb4097134ff3c332f xmlns="0c05fedb-ed2a-4eb3-93de-5f5a6c97bfe0">
-      <Terms xmlns="http://schemas.microsoft.com/office/infopath/2007/PartnerControls"/>
-    </lcf76f155ced4ddcb4097134ff3c332f>
-    <TaxCatchAll xmlns="c69d801c-64cd-49bc-b1b3-ec2496ede094" xsi:nil="true"/>
-  </documentManagement>
-</p:properties>
+<file path=customXml/itemProps1.xml><?xml version="1.0" encoding="utf-8"?>
+<ds:datastoreItem xmlns:ds="http://schemas.openxmlformats.org/officeDocument/2006/customXml" ds:itemID="{862A9E72-43F2-4CCE-8F90-EBA4919DBB42}">
+  <ds:schemaRefs>
+    <ds:schemaRef ds:uri="http://schemas.microsoft.com/office/2006/documentManagement/types"/>
+    <ds:schemaRef ds:uri="c69d801c-64cd-49bc-b1b3-ec2496ede094"/>
+    <ds:schemaRef ds:uri="http://purl.org/dc/dcmitype/"/>
+    <ds:schemaRef ds:uri="http://purl.org/dc/elements/1.1/"/>
+    <ds:schemaRef ds:uri="http://schemas.openxmlformats.org/package/2006/metadata/core-properties"/>
+    <ds:schemaRef ds:uri="http://purl.org/dc/terms/"/>
+    <ds:schemaRef ds:uri="http://www.w3.org/XML/1998/namespace"/>
+    <ds:schemaRef ds:uri="http://schemas.microsoft.com/office/infopath/2007/PartnerControls"/>
+    <ds:schemaRef ds:uri="0c05fedb-ed2a-4eb3-93de-5f5a6c97bfe0"/>
+    <ds:schemaRef ds:uri="http://schemas.microsoft.com/office/2006/metadata/properties"/>
+  </ds:schemaRefs>
+</ds:datastoreItem>
 </file>
 
-<file path=customXml/item3.xml><?xml version="1.0" encoding="utf-8"?>
-<?mso-contentType ?>
-<FormTemplates xmlns="http://schemas.microsoft.com/sharepoint/v3/contenttype/forms">
-  <Display>DocumentLibraryForm</Display>
-  <Edit>DocumentLibraryForm</Edit>
-  <New>DocumentLibraryForm</New>
-</FormTemplates>
+<file path=customXml/itemProps2.xml><?xml version="1.0" encoding="utf-8"?>
+<ds:datastoreItem xmlns:ds="http://schemas.openxmlformats.org/officeDocument/2006/customXml" ds:itemID="{957E0BBE-38AF-4179-B401-F6E82B6A5F3D}">
+  <ds:schemaRefs>
+    <ds:schemaRef ds:uri="http://schemas.microsoft.com/sharepoint/v3/contenttype/forms"/>
+  </ds:schemaRefs>
+</ds:datastoreItem>
 </file>
 
-<file path=customXml/itemProps1.xml><?xml version="1.0" encoding="utf-8"?>
+<file path=customXml/itemProps3.xml><?xml version="1.0" encoding="utf-8"?>
 <ds:datastoreItem xmlns:ds="http://schemas.openxmlformats.org/officeDocument/2006/customXml" ds:itemID="{950C4CF8-8E6C-4481-8DE0-79509E1800D4}">
   <ds:schemaRefs>
     <ds:schemaRef ds:uri="http://schemas.microsoft.com/office/2006/metadata/contentType"/>
@@ -11810,29 +11842,4 @@
     <ds:schemaRef ds:uri="http://schemas.microsoft.com/internal/obd"/>
   </ds:schemaRefs>
 </ds:datastoreItem>
-</file>
-
-<file path=customXml/itemProps2.xml><?xml version="1.0" encoding="utf-8"?>
-<ds:datastoreItem xmlns:ds="http://schemas.openxmlformats.org/officeDocument/2006/customXml" ds:itemID="{862A9E72-43F2-4CCE-8F90-EBA4919DBB42}">
-  <ds:schemaRefs>
-    <ds:schemaRef ds:uri="http://schemas.microsoft.com/office/2006/documentManagement/types"/>
-    <ds:schemaRef ds:uri="c69d801c-64cd-49bc-b1b3-ec2496ede094"/>
-    <ds:schemaRef ds:uri="http://purl.org/dc/dcmitype/"/>
-    <ds:schemaRef ds:uri="http://purl.org/dc/elements/1.1/"/>
-    <ds:schemaRef ds:uri="http://schemas.openxmlformats.org/package/2006/metadata/core-properties"/>
-    <ds:schemaRef ds:uri="http://purl.org/dc/terms/"/>
-    <ds:schemaRef ds:uri="http://www.w3.org/XML/1998/namespace"/>
-    <ds:schemaRef ds:uri="http://schemas.microsoft.com/office/infopath/2007/PartnerControls"/>
-    <ds:schemaRef ds:uri="0c05fedb-ed2a-4eb3-93de-5f5a6c97bfe0"/>
-    <ds:schemaRef ds:uri="http://schemas.microsoft.com/office/2006/metadata/properties"/>
-  </ds:schemaRefs>
-</ds:datastoreItem>
-</file>
-
-<file path=customXml/itemProps3.xml><?xml version="1.0" encoding="utf-8"?>
-<ds:datastoreItem xmlns:ds="http://schemas.openxmlformats.org/officeDocument/2006/customXml" ds:itemID="{957E0BBE-38AF-4179-B401-F6E82B6A5F3D}">
-  <ds:schemaRefs>
-    <ds:schemaRef ds:uri="http://schemas.microsoft.com/sharepoint/v3/contenttype/forms"/>
-  </ds:schemaRefs>
-</ds:datastoreItem>
 </file>
</xml_diff>